<commit_message>
Remove Premium tier, Stripe payments, and Premium page.
Drop payment APIs and nav; update PPT and docs to match free platform for all users.

Co-authored-by: Cursor <cursoragent@cursor.com>
</commit_message>
<xml_diff>
--- a/Plant_Doctor_AI_Presentation.pptx
+++ b/Plant_Doctor_AI_Presentation.pptx
@@ -24,7 +24,6 @@
     <p:sldId id="272" r:id="rId23"/>
     <p:sldId id="273" r:id="rId24"/>
     <p:sldId id="274" r:id="rId25"/>
-    <p:sldId id="275" r:id="rId26"/>
   </p:sldIdLst>
   <p:sldSz cx="12191695" cy="6858000" type="screen4x3"/>
   <p:notesSz cx="6858000" cy="9144000"/>
@@ -5511,7 +5510,7 @@
               </a:defRPr>
             </a:pPr>
             <a:r>
-              <a:t>Integrations: Stripe, SMTP/Resend, Open-Meteo</a:t>
+              <a:t>Integrations: SMTP/Resend, Open-Meteo</a:t>
             </a:r>
           </a:p>
         </p:txBody>
@@ -5798,7 +5797,7 @@
               </a:defRPr>
             </a:pPr>
             <a:r>
-              <a:t>6. Optional: Expert chat or Premium upgrade via Stripe</a:t>
+              <a:t>6. Optional: Expert chat for second opinion</a:t>
             </a:r>
           </a:p>
         </p:txBody>
@@ -6244,7 +6243,7 @@
               </a:defRPr>
             </a:pPr>
             <a:r>
-              <a:t>Monetization — Premium Tier</a:t>
+              <a:t>Conclusion &amp; Future Scope</a:t>
             </a:r>
           </a:p>
         </p:txBody>
@@ -6282,7 +6281,7 @@
               </a:defRPr>
             </a:pPr>
             <a:r>
-              <a:t>Freemium: basic scan + AI advice free for all farmers</a:t>
+              <a:t>Delivered end-to-end AI crop doctor for Pakistani farmers</a:t>
             </a:r>
           </a:p>
           <a:p>
@@ -6297,7 +6296,7 @@
               </a:defRPr>
             </a:pPr>
             <a:r>
-              <a:t>Premium: unlimited scans, priority expert, full charts</a:t>
+              <a:t>4 crops, 18 diseases, cloud auth, history, admin, expert chat</a:t>
             </a:r>
           </a:p>
           <a:p>
@@ -6312,7 +6311,7 @@
               </a:defRPr>
             </a:pPr>
             <a:r>
-              <a:t>Stripe Checkout on Railway backend</a:t>
+              <a:t>Future: Wheat, Rice, Cotton models</a:t>
             </a:r>
           </a:p>
           <a:p>
@@ -6327,7 +6326,7 @@
               </a:defRPr>
             </a:pPr>
             <a:r>
-              <a:t>Webhook activates is_premium + premium_until (30 days)</a:t>
+              <a:t>Mobile app / PWA offline with Edge AI on phone</a:t>
             </a:r>
           </a:p>
           <a:p>
@@ -6342,7 +6341,22 @@
               </a:defRPr>
             </a:pPr>
             <a:r>
-              <a:t>Sustainable model for hosting &amp; expert payouts</a:t>
+              <a:t>Regional disease heatmaps &amp; Urdu full UI toggle</a:t>
+            </a:r>
+          </a:p>
+          <a:p>
+            <a:pPr>
+              <a:spcAft>
+                <a:spcPts val="1000"/>
+              </a:spcAft>
+              <a:defRPr sz="2000">
+                <a:solidFill>
+                  <a:srgbClr val="1F2937"/>
+                </a:solidFill>
+              </a:defRPr>
+            </a:pPr>
+            <a:r>
+              <a:t>Drone imagery for large-field monitoring</a:t>
             </a:r>
           </a:p>
         </p:txBody>
@@ -6408,51 +6422,8 @@
         </p:nvSpPr>
         <p:spPr>
           <a:xfrm>
-            <a:off x="0" y="1234440"/>
-            <a:ext cx="12191695" cy="5623560"/>
-          </a:xfrm>
-          <a:prstGeom prst="rect">
-            <a:avLst/>
-          </a:prstGeom>
-          <a:solidFill>
-            <a:srgbClr val="ECFDF5"/>
-          </a:solidFill>
-          <a:ln>
-            <a:noFill/>
-          </a:ln>
-        </p:spPr>
-        <p:style>
-          <a:lnRef idx="1">
-            <a:schemeClr val="accent1"/>
-          </a:lnRef>
-          <a:fillRef idx="3">
-            <a:schemeClr val="accent1"/>
-          </a:fillRef>
-          <a:effectRef idx="2">
-            <a:schemeClr val="accent1"/>
-          </a:effectRef>
-          <a:fontRef idx="minor">
-            <a:schemeClr val="lt1"/>
-          </a:fontRef>
-        </p:style>
-        <p:txBody>
-          <a:bodyPr rtlCol="0" anchor="ctr"/>
-          <a:lstStyle/>
-          <a:p>
-            <a:pPr algn="ctr"/>
-          </a:p>
-        </p:txBody>
-      </p:sp>
-      <p:sp>
-        <p:nvSpPr>
-          <p:cNvPr id="3" name="Rectangle 2"/>
-          <p:cNvSpPr/>
-          <p:nvPr/>
-        </p:nvSpPr>
-        <p:spPr>
-          <a:xfrm>
             <a:off x="0" y="0"/>
-            <a:ext cx="12191695" cy="1234440"/>
+            <a:ext cx="12191695" cy="6858000"/>
           </a:xfrm>
           <a:prstGeom prst="rect">
             <a:avLst/>
@@ -6488,14 +6459,14 @@
       </p:sp>
       <p:sp>
         <p:nvSpPr>
-          <p:cNvPr id="4" name="TextBox 3"/>
+          <p:cNvPr id="3" name="TextBox 2"/>
           <p:cNvSpPr txBox="1"/>
           <p:nvPr/>
         </p:nvSpPr>
         <p:spPr>
           <a:xfrm>
-            <a:off x="502920" y="201168"/>
-            <a:ext cx="11155680" cy="685800"/>
+            <a:off x="731520" y="2194560"/>
+            <a:ext cx="10515600" cy="2286000"/>
           </a:xfrm>
           <a:prstGeom prst="rect">
             <a:avLst/>
@@ -6508,163 +6479,60 @@
           </a:bodyPr>
           <a:lstStyle/>
           <a:p>
-            <a:pPr>
-              <a:defRPr sz="3200" b="1">
+            <a:pPr algn="ctr">
+              <a:defRPr sz="5200" b="1">
                 <a:solidFill>
                   <a:srgbClr val="FFFFFF"/>
                 </a:solidFill>
               </a:defRPr>
             </a:pPr>
             <a:r>
-              <a:t>Conclusion &amp; Future Scope</a:t>
-            </a:r>
-          </a:p>
-        </p:txBody>
-      </p:sp>
-      <p:sp>
-        <p:nvSpPr>
-          <p:cNvPr id="5" name="TextBox 4"/>
-          <p:cNvSpPr txBox="1"/>
-          <p:nvPr/>
-        </p:nvSpPr>
-        <p:spPr>
-          <a:xfrm>
-            <a:off x="594360" y="1508760"/>
-            <a:ext cx="10972800" cy="4754880"/>
-          </a:xfrm>
-          <a:prstGeom prst="rect">
-            <a:avLst/>
-          </a:prstGeom>
-          <a:noFill/>
-        </p:spPr>
-        <p:txBody>
-          <a:bodyPr wrap="square">
-            <a:spAutoFit/>
-          </a:bodyPr>
-          <a:lstStyle/>
-          <a:p>
-            <a:pPr>
-              <a:spcAft>
-                <a:spcPts val="1000"/>
-              </a:spcAft>
+              <a:t>Thank You!</a:t>
+            </a:r>
+          </a:p>
+          <a:p>
+            <a:pPr algn="ctr">
               <a:defRPr sz="2000">
                 <a:solidFill>
-                  <a:srgbClr val="1F2937"/>
-                </a:solidFill>
-              </a:defRPr>
-            </a:pPr>
-            <a:r>
-              <a:t>Delivered end-to-end AI crop doctor for Pakistani farmers</a:t>
-            </a:r>
-          </a:p>
-          <a:p>
-            <a:pPr>
-              <a:spcAft>
-                <a:spcPts val="1000"/>
-              </a:spcAft>
+                  <a:srgbClr val="A7F3D0"/>
+                </a:solidFill>
+              </a:defRPr>
+            </a:pPr>
+            <a:r>
+              <a:t>Empowering agriculture with the speed of AI.</a:t>
+            </a:r>
+          </a:p>
+          <a:p>
+            <a:pPr algn="ctr">
               <a:defRPr sz="2000">
                 <a:solidFill>
-                  <a:srgbClr val="1F2937"/>
-                </a:solidFill>
-              </a:defRPr>
-            </a:pPr>
-            <a:r>
-              <a:t>4 crops, 18 diseases, cloud auth, history, admin, payments</a:t>
-            </a:r>
-          </a:p>
-          <a:p>
-            <a:pPr>
-              <a:spcAft>
-                <a:spcPts val="1000"/>
-              </a:spcAft>
+                  <a:srgbClr val="A7F3D0"/>
+                </a:solidFill>
+              </a:defRPr>
+            </a:pPr>
+          </a:p>
+          <a:p>
+            <a:pPr algn="ctr">
               <a:defRPr sz="2000">
                 <a:solidFill>
-                  <a:srgbClr val="1F2937"/>
-                </a:solidFill>
-              </a:defRPr>
-            </a:pPr>
-            <a:r>
-              <a:t>Future: Wheat, Rice, Cotton models</a:t>
-            </a:r>
-          </a:p>
-          <a:p>
-            <a:pPr>
-              <a:spcAft>
-                <a:spcPts val="1000"/>
-              </a:spcAft>
+                  <a:srgbClr val="A7F3D0"/>
+                </a:solidFill>
+              </a:defRPr>
+            </a:pPr>
+            <a:r>
+              <a:t>🌐 plantdoctorapp.streamlit.app</a:t>
+            </a:r>
+          </a:p>
+          <a:p>
+            <a:pPr algn="ctr">
               <a:defRPr sz="2000">
                 <a:solidFill>
-                  <a:srgbClr val="1F2937"/>
-                </a:solidFill>
-              </a:defRPr>
-            </a:pPr>
-            <a:r>
-              <a:t>Mobile app / PWA offline with Edge AI on phone</a:t>
-            </a:r>
-          </a:p>
-          <a:p>
-            <a:pPr>
-              <a:spcAft>
-                <a:spcPts val="1000"/>
-              </a:spcAft>
-              <a:defRPr sz="2000">
-                <a:solidFill>
-                  <a:srgbClr val="1F2937"/>
-                </a:solidFill>
-              </a:defRPr>
-            </a:pPr>
-            <a:r>
-              <a:t>Regional disease heatmaps &amp; Urdu full UI toggle</a:t>
-            </a:r>
-          </a:p>
-          <a:p>
-            <a:pPr>
-              <a:spcAft>
-                <a:spcPts val="1000"/>
-              </a:spcAft>
-              <a:defRPr sz="2000">
-                <a:solidFill>
-                  <a:srgbClr val="1F2937"/>
-                </a:solidFill>
-              </a:defRPr>
-            </a:pPr>
-            <a:r>
-              <a:t>Drone imagery for large-field monitoring</a:t>
-            </a:r>
-          </a:p>
-        </p:txBody>
-      </p:sp>
-      <p:sp>
-        <p:nvSpPr>
-          <p:cNvPr id="6" name="TextBox 5"/>
-          <p:cNvSpPr txBox="1"/>
-          <p:nvPr/>
-        </p:nvSpPr>
-        <p:spPr>
-          <a:xfrm>
-            <a:off x="457200" y="6446520"/>
-            <a:ext cx="11247120" cy="320040"/>
-          </a:xfrm>
-          <a:prstGeom prst="rect">
-            <a:avLst/>
-          </a:prstGeom>
-          <a:noFill/>
-        </p:spPr>
-        <p:txBody>
-          <a:bodyPr wrap="none">
-            <a:spAutoFit/>
-          </a:bodyPr>
-          <a:lstStyle/>
-          <a:p>
-            <a:pPr algn="r">
-              <a:defRPr sz="1000">
-                <a:solidFill>
-                  <a:srgbClr val="374151"/>
-                </a:solidFill>
-              </a:defRPr>
-            </a:pPr>
-            <a:r>
-              <a:t>Plant Doctor AI · FYP 2025</a:t>
+                  <a:srgbClr val="A7F3D0"/>
+                </a:solidFill>
+              </a:defRPr>
+            </a:pPr>
+            <a:r>
+              <a:t>Questions welcome from the panel.</a:t>
             </a:r>
           </a:p>
         </p:txBody>
@@ -7087,147 +6955,6 @@
 </p:sld>
 </file>
 
-<file path=ppt/slides/slide20.xml><?xml version="1.0" encoding="utf-8"?>
-<p:sld xmlns:a="http://schemas.openxmlformats.org/drawingml/2006/main" xmlns:p="http://schemas.openxmlformats.org/presentationml/2006/main" xmlns:r="http://schemas.openxmlformats.org/officeDocument/2006/relationships">
-  <p:cSld>
-    <p:spTree>
-      <p:nvGrpSpPr>
-        <p:cNvPr id="1" name=""/>
-        <p:cNvGrpSpPr/>
-        <p:nvPr/>
-      </p:nvGrpSpPr>
-      <p:grpSpPr/>
-      <p:sp>
-        <p:nvSpPr>
-          <p:cNvPr id="2" name="Rectangle 1"/>
-          <p:cNvSpPr/>
-          <p:nvPr/>
-        </p:nvSpPr>
-        <p:spPr>
-          <a:xfrm>
-            <a:off x="0" y="0"/>
-            <a:ext cx="12191695" cy="6858000"/>
-          </a:xfrm>
-          <a:prstGeom prst="rect">
-            <a:avLst/>
-          </a:prstGeom>
-          <a:solidFill>
-            <a:srgbClr val="064E3B"/>
-          </a:solidFill>
-          <a:ln>
-            <a:noFill/>
-          </a:ln>
-        </p:spPr>
-        <p:style>
-          <a:lnRef idx="1">
-            <a:schemeClr val="accent1"/>
-          </a:lnRef>
-          <a:fillRef idx="3">
-            <a:schemeClr val="accent1"/>
-          </a:fillRef>
-          <a:effectRef idx="2">
-            <a:schemeClr val="accent1"/>
-          </a:effectRef>
-          <a:fontRef idx="minor">
-            <a:schemeClr val="lt1"/>
-          </a:fontRef>
-        </p:style>
-        <p:txBody>
-          <a:bodyPr rtlCol="0" anchor="ctr"/>
-          <a:lstStyle/>
-          <a:p>
-            <a:pPr algn="ctr"/>
-          </a:p>
-        </p:txBody>
-      </p:sp>
-      <p:sp>
-        <p:nvSpPr>
-          <p:cNvPr id="3" name="TextBox 2"/>
-          <p:cNvSpPr txBox="1"/>
-          <p:nvPr/>
-        </p:nvSpPr>
-        <p:spPr>
-          <a:xfrm>
-            <a:off x="731520" y="2194560"/>
-            <a:ext cx="10515600" cy="2286000"/>
-          </a:xfrm>
-          <a:prstGeom prst="rect">
-            <a:avLst/>
-          </a:prstGeom>
-          <a:noFill/>
-        </p:spPr>
-        <p:txBody>
-          <a:bodyPr wrap="none">
-            <a:spAutoFit/>
-          </a:bodyPr>
-          <a:lstStyle/>
-          <a:p>
-            <a:pPr algn="ctr">
-              <a:defRPr sz="5200" b="1">
-                <a:solidFill>
-                  <a:srgbClr val="FFFFFF"/>
-                </a:solidFill>
-              </a:defRPr>
-            </a:pPr>
-            <a:r>
-              <a:t>Thank You!</a:t>
-            </a:r>
-          </a:p>
-          <a:p>
-            <a:pPr algn="ctr">
-              <a:defRPr sz="2000">
-                <a:solidFill>
-                  <a:srgbClr val="A7F3D0"/>
-                </a:solidFill>
-              </a:defRPr>
-            </a:pPr>
-            <a:r>
-              <a:t>Empowering agriculture with the speed of AI.</a:t>
-            </a:r>
-          </a:p>
-          <a:p>
-            <a:pPr algn="ctr">
-              <a:defRPr sz="2000">
-                <a:solidFill>
-                  <a:srgbClr val="A7F3D0"/>
-                </a:solidFill>
-              </a:defRPr>
-            </a:pPr>
-          </a:p>
-          <a:p>
-            <a:pPr algn="ctr">
-              <a:defRPr sz="2000">
-                <a:solidFill>
-                  <a:srgbClr val="A7F3D0"/>
-                </a:solidFill>
-              </a:defRPr>
-            </a:pPr>
-            <a:r>
-              <a:t>🌐 plantdoctorapp.streamlit.app</a:t>
-            </a:r>
-          </a:p>
-          <a:p>
-            <a:pPr algn="ctr">
-              <a:defRPr sz="2000">
-                <a:solidFill>
-                  <a:srgbClr val="A7F3D0"/>
-                </a:solidFill>
-              </a:defRPr>
-            </a:pPr>
-            <a:r>
-              <a:t>Questions welcome from the panel.</a:t>
-            </a:r>
-          </a:p>
-        </p:txBody>
-      </p:sp>
-    </p:spTree>
-  </p:cSld>
-  <p:clrMapOvr>
-    <a:masterClrMapping/>
-  </p:clrMapOvr>
-</p:sld>
-</file>
-
 <file path=ppt/slides/slide3.xml><?xml version="1.0" encoding="utf-8"?>
 <p:sld xmlns:a="http://schemas.openxmlformats.org/drawingml/2006/main" xmlns:p="http://schemas.openxmlformats.org/presentationml/2006/main" xmlns:r="http://schemas.openxmlformats.org/officeDocument/2006/relationships">
   <p:cSld>
@@ -7452,7 +7179,7 @@
               </a:defRPr>
             </a:pPr>
             <a:r>
-              <a:t>Expert chat &amp; Premium tier for priority support</a:t>
+              <a:t>Expert chat for farmer ↔ agricultural expert support</a:t>
             </a:r>
           </a:p>
           <a:p>
@@ -7754,21 +7481,6 @@
               </a:defRPr>
             </a:pPr>
             <a:r>
-              <a:t>Payments: Stripe Checkout + webhook → Premium activation</a:t>
-            </a:r>
-          </a:p>
-          <a:p>
-            <a:pPr>
-              <a:spcAft>
-                <a:spcPts val="1000"/>
-              </a:spcAft>
-              <a:defRPr sz="2000">
-                <a:solidFill>
-                  <a:srgbClr val="1F2937"/>
-                </a:solidFill>
-              </a:defRPr>
-            </a:pPr>
-            <a:r>
               <a:t>Email: SMTP / Resend for optional account verification</a:t>
             </a:r>
           </a:p>
@@ -8633,21 +8345,6 @@
               <a:t>🛡️ Admin panel — users, scans, platform stats</a:t>
             </a:r>
           </a:p>
-          <a:p>
-            <a:pPr>
-              <a:spcAft>
-                <a:spcPts val="1000"/>
-              </a:spcAft>
-              <a:defRPr sz="2000">
-                <a:solidFill>
-                  <a:srgbClr val="1F2937"/>
-                </a:solidFill>
-              </a:defRPr>
-            </a:pPr>
-            <a:r>
-              <a:t>👑 Premium — Stripe payments, unlimited scans priority</a:t>
-            </a:r>
-          </a:p>
         </p:txBody>
       </p:sp>
       <p:sp>
@@ -8887,7 +8584,7 @@
               </a:defRPr>
             </a:pPr>
             <a:r>
-              <a:t>Table: users — auth, roles, premium, email verification</a:t>
+              <a:t>Table: users — auth, roles, email verification</a:t>
             </a:r>
           </a:p>
           <a:p>

</xml_diff>

<commit_message>
clean: remove unused crop auto detector files and update presentation deck
</commit_message>
<xml_diff>
--- a/Plant_Doctor_AI_Presentation.pptx
+++ b/Plant_Doctor_AI_Presentation.pptx
@@ -5,27 +5,27 @@
     <p:sldMasterId id="2147483648" r:id="rId1"/>
   </p:sldMasterIdLst>
   <p:sldIdLst>
-    <p:sldId id="256" r:id="rId7"/>
-    <p:sldId id="257" r:id="rId8"/>
-    <p:sldId id="258" r:id="rId9"/>
-    <p:sldId id="259" r:id="rId10"/>
-    <p:sldId id="260" r:id="rId11"/>
-    <p:sldId id="261" r:id="rId12"/>
-    <p:sldId id="262" r:id="rId13"/>
-    <p:sldId id="263" r:id="rId14"/>
-    <p:sldId id="264" r:id="rId15"/>
-    <p:sldId id="265" r:id="rId16"/>
-    <p:sldId id="266" r:id="rId17"/>
-    <p:sldId id="267" r:id="rId18"/>
-    <p:sldId id="268" r:id="rId19"/>
-    <p:sldId id="269" r:id="rId20"/>
-    <p:sldId id="270" r:id="rId21"/>
-    <p:sldId id="271" r:id="rId22"/>
-    <p:sldId id="272" r:id="rId23"/>
-    <p:sldId id="273" r:id="rId24"/>
-    <p:sldId id="274" r:id="rId25"/>
+    <p:sldId id="256" r:id="rId2"/>
+    <p:sldId id="257" r:id="rId3"/>
+    <p:sldId id="258" r:id="rId4"/>
+    <p:sldId id="259" r:id="rId5"/>
+    <p:sldId id="260" r:id="rId6"/>
+    <p:sldId id="261" r:id="rId7"/>
+    <p:sldId id="262" r:id="rId8"/>
+    <p:sldId id="263" r:id="rId9"/>
+    <p:sldId id="264" r:id="rId10"/>
+    <p:sldId id="265" r:id="rId11"/>
+    <p:sldId id="266" r:id="rId12"/>
+    <p:sldId id="267" r:id="rId13"/>
+    <p:sldId id="268" r:id="rId14"/>
+    <p:sldId id="269" r:id="rId15"/>
+    <p:sldId id="270" r:id="rId16"/>
+    <p:sldId id="271" r:id="rId17"/>
+    <p:sldId id="272" r:id="rId18"/>
+    <p:sldId id="273" r:id="rId19"/>
+    <p:sldId id="274" r:id="rId20"/>
   </p:sldIdLst>
-  <p:sldSz cx="12191695" cy="6858000" type="screen4x3"/>
+  <p:sldSz cx="12192000" cy="6858000"/>
   <p:notesSz cx="6858000" cy="9144000"/>
   <p:defaultTextStyle>
     <a:defPPr>
@@ -122,6 +122,22 @@
       </a:defRPr>
     </a:lvl9pPr>
   </p:defaultTextStyle>
+  <p:extLst>
+    <p:ext uri="{EFAFB233-063F-42B5-8137-9DF3F51BA10A}">
+      <p15:sldGuideLst xmlns:p15="http://schemas.microsoft.com/office/powerpoint/2012/main">
+        <p15:guide id="1" orient="horz" pos="2160">
+          <p15:clr>
+            <a:srgbClr val="A4A3A4"/>
+          </p15:clr>
+        </p15:guide>
+        <p15:guide id="2" pos="2880">
+          <p15:clr>
+            <a:srgbClr val="A4A3A4"/>
+          </p15:clr>
+        </p15:guide>
+      </p15:sldGuideLst>
+    </p:ext>
+  </p:extLst>
 </p:presentation>
 </file>
 
@@ -306,7 +322,7 @@
           <a:p>
             <a:fld id="{5BCAD085-E8A6-8845-BD4E-CB4CCA059FC4}" type="datetimeFigureOut">
               <a:rPr lang="en-US" smtClean="0"/>
-              <a:t>1/27/13</a:t>
+              <a:t>5/20/2026</a:t>
             </a:fld>
             <a:endParaRPr lang="en-US"/>
           </a:p>
@@ -476,7 +492,7 @@
           <a:p>
             <a:fld id="{5BCAD085-E8A6-8845-BD4E-CB4CCA059FC4}" type="datetimeFigureOut">
               <a:rPr lang="en-US" smtClean="0"/>
-              <a:t>1/27/13</a:t>
+              <a:t>5/20/2026</a:t>
             </a:fld>
             <a:endParaRPr lang="en-US"/>
           </a:p>
@@ -656,7 +672,7 @@
           <a:p>
             <a:fld id="{5BCAD085-E8A6-8845-BD4E-CB4CCA059FC4}" type="datetimeFigureOut">
               <a:rPr lang="en-US" smtClean="0"/>
-              <a:t>1/27/13</a:t>
+              <a:t>5/20/2026</a:t>
             </a:fld>
             <a:endParaRPr lang="en-US"/>
           </a:p>
@@ -826,7 +842,7 @@
           <a:p>
             <a:fld id="{5BCAD085-E8A6-8845-BD4E-CB4CCA059FC4}" type="datetimeFigureOut">
               <a:rPr lang="en-US" smtClean="0"/>
-              <a:t>1/27/13</a:t>
+              <a:t>5/20/2026</a:t>
             </a:fld>
             <a:endParaRPr lang="en-US"/>
           </a:p>
@@ -1072,7 +1088,7 @@
           <a:p>
             <a:fld id="{5BCAD085-E8A6-8845-BD4E-CB4CCA059FC4}" type="datetimeFigureOut">
               <a:rPr lang="en-US" smtClean="0"/>
-              <a:t>1/27/13</a:t>
+              <a:t>5/20/2026</a:t>
             </a:fld>
             <a:endParaRPr lang="en-US"/>
           </a:p>
@@ -1360,7 +1376,7 @@
           <a:p>
             <a:fld id="{5BCAD085-E8A6-8845-BD4E-CB4CCA059FC4}" type="datetimeFigureOut">
               <a:rPr lang="en-US" smtClean="0"/>
-              <a:t>1/27/13</a:t>
+              <a:t>5/20/2026</a:t>
             </a:fld>
             <a:endParaRPr lang="en-US"/>
           </a:p>
@@ -1782,7 +1798,7 @@
           <a:p>
             <a:fld id="{5BCAD085-E8A6-8845-BD4E-CB4CCA059FC4}" type="datetimeFigureOut">
               <a:rPr lang="en-US" smtClean="0"/>
-              <a:t>1/27/13</a:t>
+              <a:t>5/20/2026</a:t>
             </a:fld>
             <a:endParaRPr lang="en-US"/>
           </a:p>
@@ -1900,7 +1916,7 @@
           <a:p>
             <a:fld id="{5BCAD085-E8A6-8845-BD4E-CB4CCA059FC4}" type="datetimeFigureOut">
               <a:rPr lang="en-US" smtClean="0"/>
-              <a:t>1/27/13</a:t>
+              <a:t>5/20/2026</a:t>
             </a:fld>
             <a:endParaRPr lang="en-US"/>
           </a:p>
@@ -1995,7 +2011,7 @@
           <a:p>
             <a:fld id="{5BCAD085-E8A6-8845-BD4E-CB4CCA059FC4}" type="datetimeFigureOut">
               <a:rPr lang="en-US" smtClean="0"/>
-              <a:t>1/27/13</a:t>
+              <a:t>5/20/2026</a:t>
             </a:fld>
             <a:endParaRPr lang="en-US"/>
           </a:p>
@@ -2272,7 +2288,7 @@
           <a:p>
             <a:fld id="{5BCAD085-E8A6-8845-BD4E-CB4CCA059FC4}" type="datetimeFigureOut">
               <a:rPr lang="en-US" smtClean="0"/>
-              <a:t>1/27/13</a:t>
+              <a:t>5/20/2026</a:t>
             </a:fld>
             <a:endParaRPr lang="en-US"/>
           </a:p>
@@ -2525,7 +2541,7 @@
           <a:p>
             <a:fld id="{5BCAD085-E8A6-8845-BD4E-CB4CCA059FC4}" type="datetimeFigureOut">
               <a:rPr lang="en-US" smtClean="0"/>
-              <a:t>1/27/13</a:t>
+              <a:t>5/20/2026</a:t>
             </a:fld>
             <a:endParaRPr lang="en-US"/>
           </a:p>
@@ -2738,7 +2754,7 @@
           <a:p>
             <a:fld id="{5BCAD085-E8A6-8845-BD4E-CB4CCA059FC4}" type="datetimeFigureOut">
               <a:rPr lang="en-US" smtClean="0"/>
-              <a:t>1/27/13</a:t>
+              <a:t>5/20/2026</a:t>
             </a:fld>
             <a:endParaRPr lang="en-US"/>
           </a:p>
@@ -3097,7 +3113,7 @@
 </file>
 
 <file path=ppt/slides/slide1.xml><?xml version="1.0" encoding="utf-8"?>
-<p:sld xmlns:a="http://schemas.openxmlformats.org/drawingml/2006/main" xmlns:p="http://schemas.openxmlformats.org/presentationml/2006/main" xmlns:r="http://schemas.openxmlformats.org/officeDocument/2006/relationships">
+<p:sld xmlns:a="http://schemas.openxmlformats.org/drawingml/2006/main" xmlns:r="http://schemas.openxmlformats.org/officeDocument/2006/relationships" xmlns:p="http://schemas.openxmlformats.org/presentationml/2006/main">
   <p:cSld>
     <p:spTree>
       <p:nvGrpSpPr>
@@ -3105,7 +3121,14 @@
         <p:cNvGrpSpPr/>
         <p:nvPr/>
       </p:nvGrpSpPr>
-      <p:grpSpPr/>
+      <p:grpSpPr>
+        <a:xfrm>
+          <a:off x="0" y="0"/>
+          <a:ext cx="0" cy="0"/>
+          <a:chOff x="0" y="0"/>
+          <a:chExt cx="0" cy="0"/>
+        </a:xfrm>
+      </p:grpSpPr>
       <p:sp>
         <p:nvSpPr>
           <p:cNvPr id="2" name="Rectangle 1"/>
@@ -3114,7 +3137,7 @@
         </p:nvSpPr>
         <p:spPr>
           <a:xfrm>
-            <a:off x="0" y="0"/>
+            <a:off x="8965" y="8965"/>
             <a:ext cx="12191695" cy="6858000"/>
           </a:xfrm>
           <a:prstGeom prst="rect">
@@ -3146,6 +3169,7 @@
           <a:lstStyle/>
           <a:p>
             <a:pPr algn="ctr"/>
+            <a:endParaRPr/>
           </a:p>
         </p:txBody>
       </p:sp>
@@ -3189,6 +3213,7 @@
           <a:lstStyle/>
           <a:p>
             <a:pPr algn="ctr"/>
+            <a:endParaRPr/>
           </a:p>
         </p:txBody>
       </p:sp>
@@ -3270,8 +3295,8 @@
         </p:nvSpPr>
         <p:spPr>
           <a:xfrm>
-            <a:off x="731520" y="4114800"/>
-            <a:ext cx="10515600" cy="1280160"/>
+            <a:off x="4241854" y="4114800"/>
+            <a:ext cx="3494931" cy="646331"/>
           </a:xfrm>
           <a:prstGeom prst="rect">
             <a:avLst/>
@@ -3292,7 +3317,16 @@
               </a:defRPr>
             </a:pPr>
             <a:r>
-              <a:t>Saqlain Sajjad  ·  Roll No. 225218  ·  Data Engineer</a:t>
+              <a:rPr dirty="0"/>
+              <a:t>Saqlain </a:t>
+            </a:r>
+            <a:r>
+              <a:rPr dirty="0" err="1"/>
+              <a:t>Sajjad</a:t>
+            </a:r>
+            <a:r>
+              <a:rPr dirty="0"/>
+              <a:t>  ·  Roll No. 225218  ·  </a:t>
             </a:r>
           </a:p>
           <a:p>
@@ -3304,7 +3338,12 @@
               </a:defRPr>
             </a:pPr>
             <a:r>
-              <a:t>Raheel Chishti  ·  Roll No. 225186  ·  Team Member</a:t>
+              <a:rPr dirty="0" err="1"/>
+              <a:t>Raheel</a:t>
+            </a:r>
+            <a:r>
+              <a:rPr dirty="0"/>
+              <a:t> Chishti  ·  Roll No. 225186  </a:t>
             </a:r>
           </a:p>
         </p:txBody>
@@ -3353,7 +3392,7 @@
 </file>
 
 <file path=ppt/slides/slide10.xml><?xml version="1.0" encoding="utf-8"?>
-<p:sld xmlns:a="http://schemas.openxmlformats.org/drawingml/2006/main" xmlns:p="http://schemas.openxmlformats.org/presentationml/2006/main" xmlns:r="http://schemas.openxmlformats.org/officeDocument/2006/relationships">
+<p:sld xmlns:a="http://schemas.openxmlformats.org/drawingml/2006/main" xmlns:r="http://schemas.openxmlformats.org/officeDocument/2006/relationships" xmlns:p="http://schemas.openxmlformats.org/presentationml/2006/main">
   <p:cSld>
     <p:spTree>
       <p:nvGrpSpPr>
@@ -3361,7 +3400,14 @@
         <p:cNvGrpSpPr/>
         <p:nvPr/>
       </p:nvGrpSpPr>
-      <p:grpSpPr/>
+      <p:grpSpPr>
+        <a:xfrm>
+          <a:off x="0" y="0"/>
+          <a:ext cx="0" cy="0"/>
+          <a:chOff x="0" y="0"/>
+          <a:chExt cx="0" cy="0"/>
+        </a:xfrm>
+      </p:grpSpPr>
       <p:sp>
         <p:nvSpPr>
           <p:cNvPr id="2" name="Rectangle 1"/>
@@ -3402,6 +3448,7 @@
           <a:lstStyle/>
           <a:p>
             <a:pPr algn="ctr"/>
+            <a:endParaRPr/>
           </a:p>
         </p:txBody>
       </p:sp>
@@ -3445,6 +3492,7 @@
           <a:lstStyle/>
           <a:p>
             <a:pPr algn="ctr"/>
+            <a:endParaRPr/>
           </a:p>
         </p:txBody>
       </p:sp>
@@ -3798,7 +3846,7 @@
 </file>
 
 <file path=ppt/slides/slide11.xml><?xml version="1.0" encoding="utf-8"?>
-<p:sld xmlns:a="http://schemas.openxmlformats.org/drawingml/2006/main" xmlns:p="http://schemas.openxmlformats.org/presentationml/2006/main" xmlns:r="http://schemas.openxmlformats.org/officeDocument/2006/relationships">
+<p:sld xmlns:a="http://schemas.openxmlformats.org/drawingml/2006/main" xmlns:r="http://schemas.openxmlformats.org/officeDocument/2006/relationships" xmlns:p="http://schemas.openxmlformats.org/presentationml/2006/main">
   <p:cSld>
     <p:spTree>
       <p:nvGrpSpPr>
@@ -3806,7 +3854,14 @@
         <p:cNvGrpSpPr/>
         <p:nvPr/>
       </p:nvGrpSpPr>
-      <p:grpSpPr/>
+      <p:grpSpPr>
+        <a:xfrm>
+          <a:off x="0" y="0"/>
+          <a:ext cx="0" cy="0"/>
+          <a:chOff x="0" y="0"/>
+          <a:chExt cx="0" cy="0"/>
+        </a:xfrm>
+      </p:grpSpPr>
       <p:sp>
         <p:nvSpPr>
           <p:cNvPr id="2" name="Rectangle 1"/>
@@ -3847,6 +3902,7 @@
           <a:lstStyle/>
           <a:p>
             <a:pPr algn="ctr"/>
+            <a:endParaRPr/>
           </a:p>
         </p:txBody>
       </p:sp>
@@ -3890,6 +3946,7 @@
           <a:lstStyle/>
           <a:p>
             <a:pPr algn="ctr"/>
+            <a:endParaRPr/>
           </a:p>
         </p:txBody>
       </p:sp>
@@ -4159,7 +4216,7 @@
 </file>
 
 <file path=ppt/slides/slide12.xml><?xml version="1.0" encoding="utf-8"?>
-<p:sld xmlns:a="http://schemas.openxmlformats.org/drawingml/2006/main" xmlns:p="http://schemas.openxmlformats.org/presentationml/2006/main" xmlns:r="http://schemas.openxmlformats.org/officeDocument/2006/relationships">
+<p:sld xmlns:a="http://schemas.openxmlformats.org/drawingml/2006/main" xmlns:r="http://schemas.openxmlformats.org/officeDocument/2006/relationships" xmlns:p="http://schemas.openxmlformats.org/presentationml/2006/main">
   <p:cSld>
     <p:spTree>
       <p:nvGrpSpPr>
@@ -4167,7 +4224,14 @@
         <p:cNvGrpSpPr/>
         <p:nvPr/>
       </p:nvGrpSpPr>
-      <p:grpSpPr/>
+      <p:grpSpPr>
+        <a:xfrm>
+          <a:off x="0" y="0"/>
+          <a:ext cx="0" cy="0"/>
+          <a:chOff x="0" y="0"/>
+          <a:chExt cx="0" cy="0"/>
+        </a:xfrm>
+      </p:grpSpPr>
       <p:sp>
         <p:nvSpPr>
           <p:cNvPr id="2" name="Rectangle 1"/>
@@ -4208,6 +4272,7 @@
           <a:lstStyle/>
           <a:p>
             <a:pPr algn="ctr"/>
+            <a:endParaRPr/>
           </a:p>
         </p:txBody>
       </p:sp>
@@ -4251,6 +4316,7 @@
           <a:lstStyle/>
           <a:p>
             <a:pPr algn="ctr"/>
+            <a:endParaRPr/>
           </a:p>
         </p:txBody>
       </p:sp>
@@ -4520,7 +4586,7 @@
 </file>
 
 <file path=ppt/slides/slide13.xml><?xml version="1.0" encoding="utf-8"?>
-<p:sld xmlns:a="http://schemas.openxmlformats.org/drawingml/2006/main" xmlns:p="http://schemas.openxmlformats.org/presentationml/2006/main" xmlns:r="http://schemas.openxmlformats.org/officeDocument/2006/relationships">
+<p:sld xmlns:a="http://schemas.openxmlformats.org/drawingml/2006/main" xmlns:r="http://schemas.openxmlformats.org/officeDocument/2006/relationships" xmlns:p="http://schemas.openxmlformats.org/presentationml/2006/main">
   <p:cSld>
     <p:spTree>
       <p:nvGrpSpPr>
@@ -4528,7 +4594,14 @@
         <p:cNvGrpSpPr/>
         <p:nvPr/>
       </p:nvGrpSpPr>
-      <p:grpSpPr/>
+      <p:grpSpPr>
+        <a:xfrm>
+          <a:off x="0" y="0"/>
+          <a:ext cx="0" cy="0"/>
+          <a:chOff x="0" y="0"/>
+          <a:chExt cx="0" cy="0"/>
+        </a:xfrm>
+      </p:grpSpPr>
       <p:sp>
         <p:nvSpPr>
           <p:cNvPr id="2" name="Rectangle 1"/>
@@ -4569,6 +4642,7 @@
           <a:lstStyle/>
           <a:p>
             <a:pPr algn="ctr"/>
+            <a:endParaRPr/>
           </a:p>
         </p:txBody>
       </p:sp>
@@ -4612,6 +4686,7 @@
           <a:lstStyle/>
           <a:p>
             <a:pPr algn="ctr"/>
+            <a:endParaRPr/>
           </a:p>
         </p:txBody>
       </p:sp>
@@ -4881,7 +4956,7 @@
 </file>
 
 <file path=ppt/slides/slide14.xml><?xml version="1.0" encoding="utf-8"?>
-<p:sld xmlns:a="http://schemas.openxmlformats.org/drawingml/2006/main" xmlns:p="http://schemas.openxmlformats.org/presentationml/2006/main" xmlns:r="http://schemas.openxmlformats.org/officeDocument/2006/relationships">
+<p:sld xmlns:a="http://schemas.openxmlformats.org/drawingml/2006/main" xmlns:r="http://schemas.openxmlformats.org/officeDocument/2006/relationships" xmlns:p="http://schemas.openxmlformats.org/presentationml/2006/main">
   <p:cSld>
     <p:spTree>
       <p:nvGrpSpPr>
@@ -4889,7 +4964,14 @@
         <p:cNvGrpSpPr/>
         <p:nvPr/>
       </p:nvGrpSpPr>
-      <p:grpSpPr/>
+      <p:grpSpPr>
+        <a:xfrm>
+          <a:off x="0" y="0"/>
+          <a:ext cx="0" cy="0"/>
+          <a:chOff x="0" y="0"/>
+          <a:chExt cx="0" cy="0"/>
+        </a:xfrm>
+      </p:grpSpPr>
       <p:sp>
         <p:nvSpPr>
           <p:cNvPr id="2" name="Rectangle 1"/>
@@ -4930,6 +5012,7 @@
           <a:lstStyle/>
           <a:p>
             <a:pPr algn="ctr"/>
+            <a:endParaRPr/>
           </a:p>
         </p:txBody>
       </p:sp>
@@ -4973,6 +5056,7 @@
           <a:lstStyle/>
           <a:p>
             <a:pPr algn="ctr"/>
+            <a:endParaRPr/>
           </a:p>
         </p:txBody>
       </p:sp>
@@ -5242,7 +5326,7 @@
 </file>
 
 <file path=ppt/slides/slide15.xml><?xml version="1.0" encoding="utf-8"?>
-<p:sld xmlns:a="http://schemas.openxmlformats.org/drawingml/2006/main" xmlns:p="http://schemas.openxmlformats.org/presentationml/2006/main" xmlns:r="http://schemas.openxmlformats.org/officeDocument/2006/relationships">
+<p:sld xmlns:a="http://schemas.openxmlformats.org/drawingml/2006/main" xmlns:r="http://schemas.openxmlformats.org/officeDocument/2006/relationships" xmlns:p="http://schemas.openxmlformats.org/presentationml/2006/main">
   <p:cSld>
     <p:spTree>
       <p:nvGrpSpPr>
@@ -5250,7 +5334,14 @@
         <p:cNvGrpSpPr/>
         <p:nvPr/>
       </p:nvGrpSpPr>
-      <p:grpSpPr/>
+      <p:grpSpPr>
+        <a:xfrm>
+          <a:off x="0" y="0"/>
+          <a:ext cx="0" cy="0"/>
+          <a:chOff x="0" y="0"/>
+          <a:chExt cx="0" cy="0"/>
+        </a:xfrm>
+      </p:grpSpPr>
       <p:sp>
         <p:nvSpPr>
           <p:cNvPr id="2" name="Rectangle 1"/>
@@ -5291,6 +5382,7 @@
           <a:lstStyle/>
           <a:p>
             <a:pPr algn="ctr"/>
+            <a:endParaRPr/>
           </a:p>
         </p:txBody>
       </p:sp>
@@ -5334,6 +5426,7 @@
           <a:lstStyle/>
           <a:p>
             <a:pPr algn="ctr"/>
+            <a:endParaRPr/>
           </a:p>
         </p:txBody>
       </p:sp>
@@ -5559,7 +5652,7 @@
 </file>
 
 <file path=ppt/slides/slide16.xml><?xml version="1.0" encoding="utf-8"?>
-<p:sld xmlns:a="http://schemas.openxmlformats.org/drawingml/2006/main" xmlns:p="http://schemas.openxmlformats.org/presentationml/2006/main" xmlns:r="http://schemas.openxmlformats.org/officeDocument/2006/relationships">
+<p:sld xmlns:a="http://schemas.openxmlformats.org/drawingml/2006/main" xmlns:r="http://schemas.openxmlformats.org/officeDocument/2006/relationships" xmlns:p="http://schemas.openxmlformats.org/presentationml/2006/main">
   <p:cSld>
     <p:spTree>
       <p:nvGrpSpPr>
@@ -5567,7 +5660,14 @@
         <p:cNvGrpSpPr/>
         <p:nvPr/>
       </p:nvGrpSpPr>
-      <p:grpSpPr/>
+      <p:grpSpPr>
+        <a:xfrm>
+          <a:off x="0" y="0"/>
+          <a:ext cx="0" cy="0"/>
+          <a:chOff x="0" y="0"/>
+          <a:chExt cx="0" cy="0"/>
+        </a:xfrm>
+      </p:grpSpPr>
       <p:sp>
         <p:nvSpPr>
           <p:cNvPr id="2" name="Rectangle 1"/>
@@ -5608,6 +5708,7 @@
           <a:lstStyle/>
           <a:p>
             <a:pPr algn="ctr"/>
+            <a:endParaRPr/>
           </a:p>
         </p:txBody>
       </p:sp>
@@ -5651,6 +5752,7 @@
           <a:lstStyle/>
           <a:p>
             <a:pPr algn="ctr"/>
+            <a:endParaRPr/>
           </a:p>
         </p:txBody>
       </p:sp>
@@ -5846,7 +5948,7 @@
 </file>
 
 <file path=ppt/slides/slide17.xml><?xml version="1.0" encoding="utf-8"?>
-<p:sld xmlns:a="http://schemas.openxmlformats.org/drawingml/2006/main" xmlns:p="http://schemas.openxmlformats.org/presentationml/2006/main" xmlns:r="http://schemas.openxmlformats.org/officeDocument/2006/relationships">
+<p:sld xmlns:a="http://schemas.openxmlformats.org/drawingml/2006/main" xmlns:r="http://schemas.openxmlformats.org/officeDocument/2006/relationships" xmlns:p="http://schemas.openxmlformats.org/presentationml/2006/main">
   <p:cSld>
     <p:spTree>
       <p:nvGrpSpPr>
@@ -5854,7 +5956,14 @@
         <p:cNvGrpSpPr/>
         <p:nvPr/>
       </p:nvGrpSpPr>
-      <p:grpSpPr/>
+      <p:grpSpPr>
+        <a:xfrm>
+          <a:off x="0" y="0"/>
+          <a:ext cx="0" cy="0"/>
+          <a:chOff x="0" y="0"/>
+          <a:chExt cx="0" cy="0"/>
+        </a:xfrm>
+      </p:grpSpPr>
       <p:sp>
         <p:nvSpPr>
           <p:cNvPr id="2" name="Rectangle 1"/>
@@ -5895,6 +6004,7 @@
           <a:lstStyle/>
           <a:p>
             <a:pPr algn="ctr"/>
+            <a:endParaRPr/>
           </a:p>
         </p:txBody>
       </p:sp>
@@ -5938,6 +6048,7 @@
           <a:lstStyle/>
           <a:p>
             <a:pPr algn="ctr"/>
+            <a:endParaRPr/>
           </a:p>
         </p:txBody>
       </p:sp>
@@ -6118,7 +6229,7 @@
 </file>
 
 <file path=ppt/slides/slide18.xml><?xml version="1.0" encoding="utf-8"?>
-<p:sld xmlns:a="http://schemas.openxmlformats.org/drawingml/2006/main" xmlns:p="http://schemas.openxmlformats.org/presentationml/2006/main" xmlns:r="http://schemas.openxmlformats.org/officeDocument/2006/relationships">
+<p:sld xmlns:a="http://schemas.openxmlformats.org/drawingml/2006/main" xmlns:r="http://schemas.openxmlformats.org/officeDocument/2006/relationships" xmlns:p="http://schemas.openxmlformats.org/presentationml/2006/main">
   <p:cSld>
     <p:spTree>
       <p:nvGrpSpPr>
@@ -6126,7 +6237,14 @@
         <p:cNvGrpSpPr/>
         <p:nvPr/>
       </p:nvGrpSpPr>
-      <p:grpSpPr/>
+      <p:grpSpPr>
+        <a:xfrm>
+          <a:off x="0" y="0"/>
+          <a:ext cx="0" cy="0"/>
+          <a:chOff x="0" y="0"/>
+          <a:chExt cx="0" cy="0"/>
+        </a:xfrm>
+      </p:grpSpPr>
       <p:sp>
         <p:nvSpPr>
           <p:cNvPr id="2" name="Rectangle 1"/>
@@ -6167,6 +6285,7 @@
           <a:lstStyle/>
           <a:p>
             <a:pPr algn="ctr"/>
+            <a:endParaRPr/>
           </a:p>
         </p:txBody>
       </p:sp>
@@ -6210,6 +6329,7 @@
           <a:lstStyle/>
           <a:p>
             <a:pPr algn="ctr"/>
+            <a:endParaRPr/>
           </a:p>
         </p:txBody>
       </p:sp>
@@ -6405,7 +6525,7 @@
 </file>
 
 <file path=ppt/slides/slide19.xml><?xml version="1.0" encoding="utf-8"?>
-<p:sld xmlns:a="http://schemas.openxmlformats.org/drawingml/2006/main" xmlns:p="http://schemas.openxmlformats.org/presentationml/2006/main" xmlns:r="http://schemas.openxmlformats.org/officeDocument/2006/relationships">
+<p:sld xmlns:a="http://schemas.openxmlformats.org/drawingml/2006/main" xmlns:r="http://schemas.openxmlformats.org/officeDocument/2006/relationships" xmlns:p="http://schemas.openxmlformats.org/presentationml/2006/main">
   <p:cSld>
     <p:spTree>
       <p:nvGrpSpPr>
@@ -6413,7 +6533,14 @@
         <p:cNvGrpSpPr/>
         <p:nvPr/>
       </p:nvGrpSpPr>
-      <p:grpSpPr/>
+      <p:grpSpPr>
+        <a:xfrm>
+          <a:off x="0" y="0"/>
+          <a:ext cx="0" cy="0"/>
+          <a:chOff x="0" y="0"/>
+          <a:chExt cx="0" cy="0"/>
+        </a:xfrm>
+      </p:grpSpPr>
       <p:sp>
         <p:nvSpPr>
           <p:cNvPr id="2" name="Rectangle 1"/>
@@ -6454,6 +6581,7 @@
           <a:lstStyle/>
           <a:p>
             <a:pPr algn="ctr"/>
+            <a:endParaRPr/>
           </a:p>
         </p:txBody>
       </p:sp>
@@ -6510,6 +6638,7 @@
                 </a:solidFill>
               </a:defRPr>
             </a:pPr>
+            <a:endParaRPr/>
           </a:p>
           <a:p>
             <a:pPr algn="ctr">
@@ -6546,7 +6675,7 @@
 </file>
 
 <file path=ppt/slides/slide2.xml><?xml version="1.0" encoding="utf-8"?>
-<p:sld xmlns:a="http://schemas.openxmlformats.org/drawingml/2006/main" xmlns:p="http://schemas.openxmlformats.org/presentationml/2006/main" xmlns:r="http://schemas.openxmlformats.org/officeDocument/2006/relationships">
+<p:sld xmlns:a="http://schemas.openxmlformats.org/drawingml/2006/main" xmlns:r="http://schemas.openxmlformats.org/officeDocument/2006/relationships" xmlns:p="http://schemas.openxmlformats.org/presentationml/2006/main">
   <p:cSld>
     <p:spTree>
       <p:nvGrpSpPr>
@@ -6554,7 +6683,14 @@
         <p:cNvGrpSpPr/>
         <p:nvPr/>
       </p:nvGrpSpPr>
-      <p:grpSpPr/>
+      <p:grpSpPr>
+        <a:xfrm>
+          <a:off x="0" y="0"/>
+          <a:ext cx="0" cy="0"/>
+          <a:chOff x="0" y="0"/>
+          <a:chExt cx="0" cy="0"/>
+        </a:xfrm>
+      </p:grpSpPr>
       <p:sp>
         <p:nvSpPr>
           <p:cNvPr id="2" name="Rectangle 1"/>
@@ -6595,6 +6731,7 @@
           <a:lstStyle/>
           <a:p>
             <a:pPr algn="ctr"/>
+            <a:endParaRPr/>
           </a:p>
         </p:txBody>
       </p:sp>
@@ -6638,6 +6775,7 @@
           <a:lstStyle/>
           <a:p>
             <a:pPr algn="ctr"/>
+            <a:endParaRPr/>
           </a:p>
         </p:txBody>
       </p:sp>
@@ -6699,7 +6837,7 @@
           <a:lstStyle/>
           <a:p>
             <a:pPr>
-              <a:defRPr b="1" sz="1800">
+              <a:defRPr sz="1800" b="1">
                 <a:solidFill>
                   <a:srgbClr val="064E3B"/>
                 </a:solidFill>
@@ -6817,7 +6955,7 @@
           <a:lstStyle/>
           <a:p>
             <a:pPr>
-              <a:defRPr b="1" sz="1800">
+              <a:defRPr sz="1800" b="1">
                 <a:solidFill>
                   <a:srgbClr val="064E3B"/>
                 </a:solidFill>
@@ -6956,7 +7094,7 @@
 </file>
 
 <file path=ppt/slides/slide3.xml><?xml version="1.0" encoding="utf-8"?>
-<p:sld xmlns:a="http://schemas.openxmlformats.org/drawingml/2006/main" xmlns:p="http://schemas.openxmlformats.org/presentationml/2006/main" xmlns:r="http://schemas.openxmlformats.org/officeDocument/2006/relationships">
+<p:sld xmlns:a="http://schemas.openxmlformats.org/drawingml/2006/main" xmlns:r="http://schemas.openxmlformats.org/officeDocument/2006/relationships" xmlns:p="http://schemas.openxmlformats.org/presentationml/2006/main">
   <p:cSld>
     <p:spTree>
       <p:nvGrpSpPr>
@@ -6964,7 +7102,14 @@
         <p:cNvGrpSpPr/>
         <p:nvPr/>
       </p:nvGrpSpPr>
-      <p:grpSpPr/>
+      <p:grpSpPr>
+        <a:xfrm>
+          <a:off x="0" y="0"/>
+          <a:ext cx="0" cy="0"/>
+          <a:chOff x="0" y="0"/>
+          <a:chExt cx="0" cy="0"/>
+        </a:xfrm>
+      </p:grpSpPr>
       <p:sp>
         <p:nvSpPr>
           <p:cNvPr id="2" name="Rectangle 1"/>
@@ -7005,6 +7150,7 @@
           <a:lstStyle/>
           <a:p>
             <a:pPr algn="ctr"/>
+            <a:endParaRPr/>
           </a:p>
         </p:txBody>
       </p:sp>
@@ -7048,6 +7194,7 @@
           <a:lstStyle/>
           <a:p>
             <a:pPr algn="ctr"/>
+            <a:endParaRPr/>
           </a:p>
         </p:txBody>
       </p:sp>
@@ -7243,7 +7390,7 @@
 </file>
 
 <file path=ppt/slides/slide4.xml><?xml version="1.0" encoding="utf-8"?>
-<p:sld xmlns:a="http://schemas.openxmlformats.org/drawingml/2006/main" xmlns:p="http://schemas.openxmlformats.org/presentationml/2006/main" xmlns:r="http://schemas.openxmlformats.org/officeDocument/2006/relationships">
+<p:sld xmlns:a="http://schemas.openxmlformats.org/drawingml/2006/main" xmlns:r="http://schemas.openxmlformats.org/officeDocument/2006/relationships" xmlns:p="http://schemas.openxmlformats.org/presentationml/2006/main">
   <p:cSld>
     <p:spTree>
       <p:nvGrpSpPr>
@@ -7251,7 +7398,14 @@
         <p:cNvGrpSpPr/>
         <p:nvPr/>
       </p:nvGrpSpPr>
-      <p:grpSpPr/>
+      <p:grpSpPr>
+        <a:xfrm>
+          <a:off x="0" y="0"/>
+          <a:ext cx="0" cy="0"/>
+          <a:chOff x="0" y="0"/>
+          <a:chExt cx="0" cy="0"/>
+        </a:xfrm>
+      </p:grpSpPr>
       <p:sp>
         <p:nvSpPr>
           <p:cNvPr id="2" name="Rectangle 1"/>
@@ -7292,6 +7446,7 @@
           <a:lstStyle/>
           <a:p>
             <a:pPr algn="ctr"/>
+            <a:endParaRPr/>
           </a:p>
         </p:txBody>
       </p:sp>
@@ -7335,6 +7490,7 @@
           <a:lstStyle/>
           <a:p>
             <a:pPr algn="ctr"/>
+            <a:endParaRPr/>
           </a:p>
         </p:txBody>
       </p:sp>
@@ -7530,7 +7686,7 @@
 </file>
 
 <file path=ppt/slides/slide5.xml><?xml version="1.0" encoding="utf-8"?>
-<p:sld xmlns:a="http://schemas.openxmlformats.org/drawingml/2006/main" xmlns:p="http://schemas.openxmlformats.org/presentationml/2006/main" xmlns:r="http://schemas.openxmlformats.org/officeDocument/2006/relationships">
+<p:sld xmlns:a="http://schemas.openxmlformats.org/drawingml/2006/main" xmlns:r="http://schemas.openxmlformats.org/officeDocument/2006/relationships" xmlns:p="http://schemas.openxmlformats.org/presentationml/2006/main">
   <p:cSld>
     <p:spTree>
       <p:nvGrpSpPr>
@@ -7538,7 +7694,14 @@
         <p:cNvGrpSpPr/>
         <p:nvPr/>
       </p:nvGrpSpPr>
-      <p:grpSpPr/>
+      <p:grpSpPr>
+        <a:xfrm>
+          <a:off x="0" y="0"/>
+          <a:ext cx="0" cy="0"/>
+          <a:chOff x="0" y="0"/>
+          <a:chExt cx="0" cy="0"/>
+        </a:xfrm>
+      </p:grpSpPr>
       <p:sp>
         <p:nvSpPr>
           <p:cNvPr id="2" name="Rectangle 1"/>
@@ -7579,6 +7742,7 @@
           <a:lstStyle/>
           <a:p>
             <a:pPr algn="ctr"/>
+            <a:endParaRPr/>
           </a:p>
         </p:txBody>
       </p:sp>
@@ -7622,6 +7786,7 @@
           <a:lstStyle/>
           <a:p>
             <a:pPr algn="ctr"/>
+            <a:endParaRPr/>
           </a:p>
         </p:txBody>
       </p:sp>
@@ -7817,7 +7982,7 @@
 </file>
 
 <file path=ppt/slides/slide6.xml><?xml version="1.0" encoding="utf-8"?>
-<p:sld xmlns:a="http://schemas.openxmlformats.org/drawingml/2006/main" xmlns:p="http://schemas.openxmlformats.org/presentationml/2006/main" xmlns:r="http://schemas.openxmlformats.org/officeDocument/2006/relationships">
+<p:sld xmlns:a="http://schemas.openxmlformats.org/drawingml/2006/main" xmlns:r="http://schemas.openxmlformats.org/officeDocument/2006/relationships" xmlns:p="http://schemas.openxmlformats.org/presentationml/2006/main">
   <p:cSld>
     <p:spTree>
       <p:nvGrpSpPr>
@@ -7825,7 +7990,14 @@
         <p:cNvGrpSpPr/>
         <p:nvPr/>
       </p:nvGrpSpPr>
-      <p:grpSpPr/>
+      <p:grpSpPr>
+        <a:xfrm>
+          <a:off x="0" y="0"/>
+          <a:ext cx="0" cy="0"/>
+          <a:chOff x="0" y="0"/>
+          <a:chExt cx="0" cy="0"/>
+        </a:xfrm>
+      </p:grpSpPr>
       <p:sp>
         <p:nvSpPr>
           <p:cNvPr id="2" name="Rectangle 1"/>
@@ -7866,6 +8038,7 @@
           <a:lstStyle/>
           <a:p>
             <a:pPr algn="ctr"/>
+            <a:endParaRPr/>
           </a:p>
         </p:txBody>
       </p:sp>
@@ -7909,6 +8082,7 @@
           <a:lstStyle/>
           <a:p>
             <a:pPr algn="ctr"/>
+            <a:endParaRPr/>
           </a:p>
         </p:txBody>
       </p:sp>
@@ -8089,7 +8263,7 @@
 </file>
 
 <file path=ppt/slides/slide7.xml><?xml version="1.0" encoding="utf-8"?>
-<p:sld xmlns:a="http://schemas.openxmlformats.org/drawingml/2006/main" xmlns:p="http://schemas.openxmlformats.org/presentationml/2006/main" xmlns:r="http://schemas.openxmlformats.org/officeDocument/2006/relationships">
+<p:sld xmlns:a="http://schemas.openxmlformats.org/drawingml/2006/main" xmlns:r="http://schemas.openxmlformats.org/officeDocument/2006/relationships" xmlns:p="http://schemas.openxmlformats.org/presentationml/2006/main">
   <p:cSld>
     <p:spTree>
       <p:nvGrpSpPr>
@@ -8097,7 +8271,14 @@
         <p:cNvGrpSpPr/>
         <p:nvPr/>
       </p:nvGrpSpPr>
-      <p:grpSpPr/>
+      <p:grpSpPr>
+        <a:xfrm>
+          <a:off x="0" y="0"/>
+          <a:ext cx="0" cy="0"/>
+          <a:chOff x="0" y="0"/>
+          <a:chExt cx="0" cy="0"/>
+        </a:xfrm>
+      </p:grpSpPr>
       <p:sp>
         <p:nvSpPr>
           <p:cNvPr id="2" name="Rectangle 1"/>
@@ -8138,6 +8319,7 @@
           <a:lstStyle/>
           <a:p>
             <a:pPr algn="ctr"/>
+            <a:endParaRPr/>
           </a:p>
         </p:txBody>
       </p:sp>
@@ -8181,6 +8363,7 @@
           <a:lstStyle/>
           <a:p>
             <a:pPr algn="ctr"/>
+            <a:endParaRPr/>
           </a:p>
         </p:txBody>
       </p:sp>
@@ -8391,7 +8574,7 @@
 </file>
 
 <file path=ppt/slides/slide8.xml><?xml version="1.0" encoding="utf-8"?>
-<p:sld xmlns:a="http://schemas.openxmlformats.org/drawingml/2006/main" xmlns:p="http://schemas.openxmlformats.org/presentationml/2006/main" xmlns:r="http://schemas.openxmlformats.org/officeDocument/2006/relationships">
+<p:sld xmlns:a="http://schemas.openxmlformats.org/drawingml/2006/main" xmlns:r="http://schemas.openxmlformats.org/officeDocument/2006/relationships" xmlns:p="http://schemas.openxmlformats.org/presentationml/2006/main">
   <p:cSld>
     <p:spTree>
       <p:nvGrpSpPr>
@@ -8399,7 +8582,14 @@
         <p:cNvGrpSpPr/>
         <p:nvPr/>
       </p:nvGrpSpPr>
-      <p:grpSpPr/>
+      <p:grpSpPr>
+        <a:xfrm>
+          <a:off x="0" y="0"/>
+          <a:ext cx="0" cy="0"/>
+          <a:chOff x="0" y="0"/>
+          <a:chExt cx="0" cy="0"/>
+        </a:xfrm>
+      </p:grpSpPr>
       <p:sp>
         <p:nvSpPr>
           <p:cNvPr id="2" name="Rectangle 1"/>
@@ -8440,6 +8630,7 @@
           <a:lstStyle/>
           <a:p>
             <a:pPr algn="ctr"/>
+            <a:endParaRPr/>
           </a:p>
         </p:txBody>
       </p:sp>
@@ -8483,6 +8674,7 @@
           <a:lstStyle/>
           <a:p>
             <a:pPr algn="ctr"/>
+            <a:endParaRPr/>
           </a:p>
         </p:txBody>
       </p:sp>
@@ -8693,7 +8885,7 @@
 </file>
 
 <file path=ppt/slides/slide9.xml><?xml version="1.0" encoding="utf-8"?>
-<p:sld xmlns:a="http://schemas.openxmlformats.org/drawingml/2006/main" xmlns:p="http://schemas.openxmlformats.org/presentationml/2006/main" xmlns:r="http://schemas.openxmlformats.org/officeDocument/2006/relationships">
+<p:sld xmlns:a="http://schemas.openxmlformats.org/drawingml/2006/main" xmlns:r="http://schemas.openxmlformats.org/officeDocument/2006/relationships" xmlns:p="http://schemas.openxmlformats.org/presentationml/2006/main">
   <p:cSld>
     <p:spTree>
       <p:nvGrpSpPr>
@@ -8701,7 +8893,14 @@
         <p:cNvGrpSpPr/>
         <p:nvPr/>
       </p:nvGrpSpPr>
-      <p:grpSpPr/>
+      <p:grpSpPr>
+        <a:xfrm>
+          <a:off x="0" y="0"/>
+          <a:ext cx="0" cy="0"/>
+          <a:chOff x="0" y="0"/>
+          <a:chExt cx="0" cy="0"/>
+        </a:xfrm>
+      </p:grpSpPr>
       <p:sp>
         <p:nvSpPr>
           <p:cNvPr id="2" name="Rectangle 1"/>
@@ -8742,6 +8941,7 @@
           <a:lstStyle/>
           <a:p>
             <a:pPr algn="ctr"/>
+            <a:endParaRPr/>
           </a:p>
         </p:txBody>
       </p:sp>
@@ -8785,6 +8985,7 @@
           <a:lstStyle/>
           <a:p>
             <a:pPr algn="ctr"/>
+            <a:endParaRPr/>
           </a:p>
         </p:txBody>
       </p:sp>
@@ -8900,6 +9101,7 @@
           <a:lstStyle/>
           <a:p>
             <a:pPr algn="ctr"/>
+            <a:endParaRPr/>
           </a:p>
         </p:txBody>
       </p:sp>
@@ -9120,6 +9322,7 @@
           <a:lstStyle/>
           <a:p>
             <a:pPr algn="ctr"/>
+            <a:endParaRPr/>
           </a:p>
         </p:txBody>
       </p:sp>
@@ -9340,6 +9543,7 @@
           <a:lstStyle/>
           <a:p>
             <a:pPr algn="ctr"/>
+            <a:endParaRPr/>
           </a:p>
         </p:txBody>
       </p:sp>
@@ -9560,6 +9764,7 @@
           <a:lstStyle/>
           <a:p>
             <a:pPr algn="ctr"/>
+            <a:endParaRPr/>
           </a:p>
         </p:txBody>
       </p:sp>

</xml_diff>